<commit_message>
Retarget to Terasic DE2-115: 50 MHz, UART AI link and telemetry, board wrapper, host software, constraints, updated deck and diagram
Co-Authored-By: Claude Sonnet 5.5 <noreply@anthropic.com>
Claude-Session: https://claude.ai/code/session_01QAYZ6QSpvYPFSn8hrbYx5j
</commit_message>
<xml_diff>
--- a/docs/tactile_reflex_system.pptx
+++ b/docs/tactile_reflex_system.pptx
@@ -3116,7 +3116,7 @@
                   <a:schemeClr val="accent2"/>
                 </a:solidFill>
               </a:rPr>
-              <a:t>Verilog design, verification and AI/ML evaluation</a:t>
+              <a:t>Terasic DE2-115  |  Verilog design, verification and AI/ML evaluation</a:t>
             </a:r>
             <a:endParaRPr lang="en-US" sz="1400" dirty="0"/>
           </a:p>
@@ -3242,7 +3242,7 @@
                   <a:schemeClr val="accent1"/>
                 </a:solidFill>
               </a:rPr>
-              <a:t>134 / 134</a:t>
+              <a:t>167 / 167</a:t>
             </a:r>
             <a:endParaRPr lang="en-US" sz="3200" dirty="0"/>
           </a:p>
@@ -3278,7 +3278,7 @@
                   <a:schemeClr val="tx1"/>
                 </a:solidFill>
               </a:rPr>
-              <a:t>directed checks pass across 8 testbenches</a:t>
+              <a:t>directed checks pass across 10 testbenches</a:t>
             </a:r>
             <a:endParaRPr lang="en-US" sz="1400" dirty="0"/>
           </a:p>
@@ -4167,7 +4167,7 @@
                   <a:schemeClr val="accent5"/>
                 </a:solidFill>
               </a:rPr>
-              <a:t>RTL simulation, 100 MHz clock</a:t>
+              <a:t>RTL simulation, 50 MHz clock</a:t>
             </a:r>
             <a:endParaRPr lang="en-US" sz="1000" dirty="0"/>
           </a:p>
@@ -4632,7 +4632,7 @@
                   <a:schemeClr val="accent5"/>
                 </a:solidFill>
               </a:rPr>
-              <a:t>RTL simulation, 100 MHz clock</a:t>
+              <a:t>RTL simulation, 50 MHz clock</a:t>
             </a:r>
             <a:endParaRPr lang="en-US" sz="1000" dirty="0"/>
           </a:p>
@@ -4803,7 +4803,7 @@
                   <a:schemeClr val="accent1"/>
                 </a:solidFill>
               </a:rPr>
-              <a:t>40 ns</a:t>
+              <a:t>80 ns</a:t>
             </a:r>
             <a:endParaRPr lang="en-US" sz="3200" dirty="0"/>
           </a:p>
@@ -4839,7 +4839,7 @@
                   <a:schemeClr val="tx1"/>
                 </a:solidFill>
               </a:rPr>
-              <a:t>ADC sample to PWM low: 4 clock cycles, jitter 0</a:t>
+              <a:t>ADC sample to PWM low: 4 clock cycles at 50 MHz, jitter 0</a:t>
             </a:r>
             <a:endParaRPr lang="en-US" sz="1400" dirty="0"/>
           </a:p>
@@ -4902,7 +4902,7 @@
                   <a:schemeClr val="accent1"/>
                 </a:solidFill>
               </a:rPr>
-              <a:t>50 ns</a:t>
+              <a:t>100 ns</a:t>
             </a:r>
             <a:endParaRPr lang="en-US" sz="3200" dirty="0"/>
           </a:p>
@@ -5001,7 +5001,7 @@
                   <a:schemeClr val="bg1"/>
                 </a:solidFill>
               </a:rPr>
-              <a:t>1.68 us</a:t>
+              <a:t>2.08 us</a:t>
             </a:r>
             <a:endParaRPr lang="en-US" sz="3200" dirty="0"/>
           </a:p>
@@ -5037,7 +5037,7 @@
                   <a:schemeClr val="bg1"/>
                 </a:solidFill>
               </a:rPr>
-              <a:t>ADC frame time: 168 cycles at 10 MHz SCLK</a:t>
+              <a:t>ADC frame time: 104 cycles at 8.33 MHz SCLK</a:t>
             </a:r>
             <a:endParaRPr lang="en-US" sz="1400" dirty="0"/>
           </a:p>
@@ -5100,7 +5100,7 @@
                   <a:schemeClr val="bg1"/>
                 </a:solidFill>
               </a:rPr>
-              <a:t>1.65 - 3.20 us</a:t>
+              <a:t>2.10 - 3.84 us</a:t>
             </a:r>
             <a:endParaRPr lang="en-US" sz="2800" dirty="0"/>
           </a:p>
@@ -5136,7 +5136,7 @@
                   <a:schemeClr val="bg1"/>
                 </a:solidFill>
               </a:rPr>
-              <a:t>Input change to PWM low; jitter 1.55 us from ADC frame phase</a:t>
+              <a:t>Input change to PWM low; jitter 1.74 us from ADC frame phase</a:t>
             </a:r>
             <a:endParaRPr lang="en-US" sz="1400" dirty="0"/>
           </a:p>
@@ -5172,7 +5172,7 @@
                   <a:schemeClr val="accent5"/>
                 </a:solidFill>
               </a:rPr>
-              <a:t>RTL simulation, 100 MHz clock, behavioural ADC model. T_FPGA is reported separately from T_ML.</a:t>
+              <a:t>RTL simulation, 50 MHz clock, behavioural ADC model. T_FPGA is reported separately from T_ML.</a:t>
             </a:r>
             <a:endParaRPr lang="en-US" sz="1200" dirty="0"/>
           </a:p>
@@ -5883,7 +5883,7 @@
                   <a:schemeClr val="tx2"/>
                 </a:solidFill>
               </a:rPr>
-              <a:t>Output maps to control states sent to the PL.</a:t>
+              <a:t>Output maps to control states sent to the FPGA.</a:t>
             </a:r>
             <a:endParaRPr lang="en-US" sz="1400" dirty="0"/>
           </a:p>
@@ -8824,7 +8824,7 @@
                   <a:schemeClr val="tx1"/>
                 </a:solidFill>
               </a:rPr>
-              <a:t>Classifies contact, grip condition and force category. Predicts excessive force. Runs on the processor in microseconds to milliseconds. May be wrong or absent.</a:t>
+              <a:t>Classifies contact, grip condition and force category. Predicts excessive force. Runs on a laptop over a UART link. May be wrong, late or absent.</a:t>
             </a:r>
             <a:endParaRPr lang="en-US" sz="1600" dirty="0"/>
           </a:p>
@@ -10435,7 +10435,7 @@
                   <a:schemeClr val="bg2"/>
                 </a:solidFill>
               </a:rPr>
-              <a:t>134 directed checks and 3,600 replayed vectors confirm the override behaviour in simulation.</a:t>
+              <a:t>167 directed checks and 3,600 replayed vectors confirm the override behaviour in simulation.</a:t>
             </a:r>
             <a:endParaRPr lang="en-US" sz="1800" dirty="0"/>
           </a:p>
@@ -10810,7 +10810,7 @@
                             <a:schemeClr val="tx1"/>
                           </a:solidFill>
                         </a:rPr>
-                        <a:t>Open Verilog, 134 directed checks, replay with an adversarial AI</a:t>
+                        <a:t>Open Verilog, 167 directed checks, replay with an adversarial AI</a:t>
                       </a:r>
                       <a:endParaRPr lang="en-US" sz="1400" dirty="0"/>
                     </a:p>
@@ -11088,7 +11088,7 @@
                   <a:schemeClr val="accent1"/>
                 </a:solidFill>
               </a:rPr>
-              <a:t>PL (FPGA fabric): safety-critical reflex path</a:t>
+              <a:t>FPGA (Cyclone IV E): safety-critical reflex path</a:t>
             </a:r>
             <a:endParaRPr lang="en-US" sz="1200" dirty="0"/>
           </a:p>
@@ -11820,7 +11820,7 @@
                   <a:schemeClr val="accent3"/>
                 </a:solidFill>
               </a:rPr>
-              <a:t>advisory class + heartbeat</a:t>
+              <a:t>advisory class over UART</a:t>
             </a:r>
             <a:endParaRPr lang="en-US" sz="1200" dirty="0"/>
           </a:p>
@@ -11856,7 +11856,7 @@
                   <a:schemeClr val="accent5"/>
                 </a:solidFill>
               </a:rPr>
-              <a:t>PS (processor): AI/ML, logging, visualization</a:t>
+              <a:t>Laptop (UART link): AI/ML, logging, visualization</a:t>
             </a:r>
             <a:endParaRPr lang="en-US" sz="1200" dirty="0"/>
           </a:p>
@@ -12008,7 +12008,7 @@
       </p:sp>
       <p:pic>
         <p:nvPicPr>
-          <p:cNvPr id="3" name="Image 0" descr="Wiring schematic: FSR divider, Pmod AD1, PYNQ-Z2, DRV8871, motor, e-stop">    </p:cNvPr>
+          <p:cNvPr id="3" name="Image 0" descr="Wiring schematic: FSR divider, Pmod AD1, DE2-115, DRV8871, motor, e-stop">    </p:cNvPr>
           <p:cNvPicPr>
             <a:picLocks noChangeAspect="1"/>
           </p:cNvPicPr>
@@ -12464,7 +12464,7 @@
       </p:sp>
       <p:pic>
         <p:nvPicPr>
-          <p:cNvPr id="4" name="Image 0" descr="Photo placeholder: PYNQ-Z2">    </p:cNvPr>
+          <p:cNvPr id="4" name="Image 0" descr="Photo placeholder: DE2-115">    </p:cNvPr>
           <p:cNvPicPr>
             <a:picLocks noChangeAspect="1"/>
           </p:cNvPicPr>
@@ -12516,7 +12516,7 @@
                   <a:schemeClr val="tx2"/>
                 </a:solidFill>
               </a:rPr>
-              <a:t>PYNQ-Z2</a:t>
+              <a:t>DE2-115</a:t>
             </a:r>
             <a:endParaRPr lang="en-US" sz="1600" dirty="0"/>
           </a:p>
@@ -12556,7 +12556,7 @@
                   <a:schemeClr val="tx1"/>
                 </a:solidFill>
               </a:rPr>
-              <a:t>Zynq-7020: dual ARM A9 + FPGA</a:t>
+              <a:t>Cyclone IV E EP4CE115 FPGA</a:t>
             </a:r>
             <a:endParaRPr lang="en-US" sz="1400" dirty="0"/>
           </a:p>
@@ -12574,7 +12574,7 @@
                   <a:schemeClr val="tx1"/>
                 </a:solidFill>
               </a:rPr>
-              <a:t>PL: reflex path; PS: AI/ML</a:t>
+              <a:t>50 MHz clock, RS-232 port</a:t>
             </a:r>
             <a:endParaRPr lang="en-US" sz="1400" dirty="0"/>
           </a:p>
@@ -12592,7 +12592,7 @@
                   <a:schemeClr val="tx1"/>
                 </a:solidFill>
               </a:rPr>
-              <a:t>Pmod and Arduino headers</a:t>
+              <a:t>40-pin 3.3 V GPIO header</a:t>
             </a:r>
             <a:endParaRPr lang="en-US" sz="1400" dirty="0"/>
           </a:p>
@@ -12755,7 +12755,7 @@
                   <a:schemeClr val="tx1"/>
                 </a:solidFill>
               </a:rPr>
-              <a:t>0 to 3.3 V analog input</a:t>
+              <a:t>Wired to the GPIO header</a:t>
             </a:r>
             <a:endParaRPr lang="en-US" sz="1400" dirty="0"/>
           </a:p>
@@ -14358,7 +14358,7 @@
                 <a:gridCol w="4114800"/>
                 <a:gridCol w="1645920"/>
               </a:tblGrid>
-              <a:tr h="365760">
+              <a:tr h="310896">
                 <a:tc>
                   <a:txBody>
                     <a:bodyPr/>
@@ -14471,7 +14471,7 @@
                   </a:tcPr>
                 </a:tc>
               </a:tr>
-              <a:tr h="365760">
+              <a:tr h="310896">
                 <a:tc>
                   <a:txBody>
                     <a:bodyPr/>
@@ -14584,7 +14584,7 @@
                   </a:tcPr>
                 </a:tc>
               </a:tr>
-              <a:tr h="365760">
+              <a:tr h="310896">
                 <a:tc>
                   <a:txBody>
                     <a:bodyPr/>
@@ -14697,7 +14697,7 @@
                   </a:tcPr>
                 </a:tc>
               </a:tr>
-              <a:tr h="365760">
+              <a:tr h="310896">
                 <a:tc>
                   <a:txBody>
                     <a:bodyPr/>
@@ -14810,7 +14810,7 @@
                   </a:tcPr>
                 </a:tc>
               </a:tr>
-              <a:tr h="365760">
+              <a:tr h="310896">
                 <a:tc>
                   <a:txBody>
                     <a:bodyPr/>
@@ -14923,7 +14923,7 @@
                   </a:tcPr>
                 </a:tc>
               </a:tr>
-              <a:tr h="365760">
+              <a:tr h="310896">
                 <a:tc>
                   <a:txBody>
                     <a:bodyPr/>
@@ -14975,7 +14975,7 @@
                             <a:schemeClr val="tx1"/>
                           </a:solidFill>
                         </a:rPr>
-                        <a:t>24.4 kHz PWM, instant kill</a:t>
+                        <a:t>12.2 kHz PWM, instant kill</a:t>
                       </a:r>
                       <a:endParaRPr lang="en-US" sz="1400" dirty="0"/>
                     </a:p>
@@ -15036,7 +15036,7 @@
                   </a:tcPr>
                 </a:tc>
               </a:tr>
-              <a:tr h="365760">
+              <a:tr h="310896">
                 <a:tc>
                   <a:txBody>
                     <a:bodyPr/>
@@ -15149,7 +15149,7 @@
                   </a:tcPr>
                 </a:tc>
               </a:tr>
-              <a:tr h="365760">
+              <a:tr h="310896">
                 <a:tc>
                   <a:txBody>
                     <a:bodyPr/>
@@ -15262,7 +15262,120 @@
                   </a:tcPr>
                 </a:tc>
               </a:tr>
-              <a:tr h="365760">
+              <a:tr h="310896">
+                <a:tc>
+                  <a:txBody>
+                    <a:bodyPr/>
+                    <a:lstStyle/>
+                    <a:p>
+                      <a:pPr algn="l" indent="0" marL="0">
+                        <a:buNone/>
+                      </a:pPr>
+                      <a:r>
+                        <a:rPr lang="en-US" sz="1400" dirty="0">
+                          <a:solidFill>
+                            <a:schemeClr val="tx1"/>
+                          </a:solidFill>
+                        </a:rPr>
+                        <a:t>UART link</a:t>
+                      </a:r>
+                      <a:endParaRPr lang="en-US" sz="1400" dirty="0"/>
+                    </a:p>
+                  </a:txBody>
+                  <a:tcPr marL="91440" marR="91440" marT="45720" marB="45720" anchor="ctr">
+                    <a:lnL w="0" cap="flat" cmpd="sng" algn="ctr">
+                      <a:noFill/>
+                    </a:lnL>
+                    <a:lnR w="0" cap="flat" cmpd="sng" algn="ctr">
+                      <a:noFill/>
+                    </a:lnR>
+                    <a:lnT w="0" cap="flat" cmpd="sng" algn="ctr">
+                      <a:noFill/>
+                    </a:lnT>
+                    <a:lnB w="0" cap="flat" cmpd="sng" algn="ctr">
+                      <a:noFill/>
+                    </a:lnB>
+                    <a:solidFill>
+                      <a:schemeClr val="bg1"/>
+                    </a:solidFill>
+                  </a:tcPr>
+                </a:tc>
+                <a:tc>
+                  <a:txBody>
+                    <a:bodyPr/>
+                    <a:lstStyle/>
+                    <a:p>
+                      <a:pPr algn="l" indent="0" marL="0">
+                        <a:buNone/>
+                      </a:pPr>
+                      <a:r>
+                        <a:rPr lang="en-US" sz="1400" dirty="0">
+                          <a:solidFill>
+                            <a:schemeClr val="tx1"/>
+                          </a:solidFill>
+                        </a:rPr>
+                        <a:t>AI packets in, telemetry out</a:t>
+                      </a:r>
+                      <a:endParaRPr lang="en-US" sz="1400" dirty="0"/>
+                    </a:p>
+                  </a:txBody>
+                  <a:tcPr marL="91440" marR="91440" marT="45720" marB="45720" anchor="ctr">
+                    <a:lnL w="0" cap="flat" cmpd="sng" algn="ctr">
+                      <a:noFill/>
+                    </a:lnL>
+                    <a:lnR w="0" cap="flat" cmpd="sng" algn="ctr">
+                      <a:noFill/>
+                    </a:lnR>
+                    <a:lnT w="0" cap="flat" cmpd="sng" algn="ctr">
+                      <a:noFill/>
+                    </a:lnT>
+                    <a:lnB w="0" cap="flat" cmpd="sng" algn="ctr">
+                      <a:noFill/>
+                    </a:lnB>
+                    <a:solidFill>
+                      <a:schemeClr val="bg1"/>
+                    </a:solidFill>
+                  </a:tcPr>
+                </a:tc>
+                <a:tc>
+                  <a:txBody>
+                    <a:bodyPr/>
+                    <a:lstStyle/>
+                    <a:p>
+                      <a:pPr algn="r" indent="0" marL="0">
+                        <a:buNone/>
+                      </a:pPr>
+                      <a:r>
+                        <a:rPr lang="en-US" sz="1400" dirty="0">
+                          <a:solidFill>
+                            <a:schemeClr val="tx1"/>
+                          </a:solidFill>
+                        </a:rPr>
+                        <a:t>15</a:t>
+                      </a:r>
+                      <a:endParaRPr lang="en-US" sz="1400" dirty="0"/>
+                    </a:p>
+                  </a:txBody>
+                  <a:tcPr marL="91440" marR="91440" marT="45720" marB="45720" anchor="ctr">
+                    <a:lnL w="0" cap="flat" cmpd="sng" algn="ctr">
+                      <a:noFill/>
+                    </a:lnL>
+                    <a:lnR w="0" cap="flat" cmpd="sng" algn="ctr">
+                      <a:noFill/>
+                    </a:lnR>
+                    <a:lnT w="0" cap="flat" cmpd="sng" algn="ctr">
+                      <a:noFill/>
+                    </a:lnT>
+                    <a:lnB w="0" cap="flat" cmpd="sng" algn="ctr">
+                      <a:noFill/>
+                    </a:lnB>
+                    <a:solidFill>
+                      <a:schemeClr val="bg1"/>
+                    </a:solidFill>
+                  </a:tcPr>
+                </a:tc>
+              </a:tr>
+              <a:tr h="310896">
                 <a:tc>
                   <a:txBody>
                     <a:bodyPr/>
@@ -15296,7 +15409,7 @@
                       <a:noFill/>
                     </a:lnB>
                     <a:solidFill>
-                      <a:schemeClr val="bg1"/>
+                      <a:schemeClr val="bg2"/>
                     </a:solidFill>
                   </a:tcPr>
                 </a:tc>
@@ -15333,6 +15446,119 @@
                       <a:noFill/>
                     </a:lnB>
                     <a:solidFill>
+                      <a:schemeClr val="bg2"/>
+                    </a:solidFill>
+                  </a:tcPr>
+                </a:tc>
+                <a:tc>
+                  <a:txBody>
+                    <a:bodyPr/>
+                    <a:lstStyle/>
+                    <a:p>
+                      <a:pPr algn="r" indent="0" marL="0">
+                        <a:buNone/>
+                      </a:pPr>
+                      <a:r>
+                        <a:rPr lang="en-US" sz="1400" dirty="0">
+                          <a:solidFill>
+                            <a:schemeClr val="tx1"/>
+                          </a:solidFill>
+                        </a:rPr>
+                        <a:t>44</a:t>
+                      </a:r>
+                      <a:endParaRPr lang="en-US" sz="1400" dirty="0"/>
+                    </a:p>
+                  </a:txBody>
+                  <a:tcPr marL="91440" marR="91440" marT="45720" marB="45720" anchor="ctr">
+                    <a:lnL w="0" cap="flat" cmpd="sng" algn="ctr">
+                      <a:noFill/>
+                    </a:lnL>
+                    <a:lnR w="0" cap="flat" cmpd="sng" algn="ctr">
+                      <a:noFill/>
+                    </a:lnR>
+                    <a:lnT w="0" cap="flat" cmpd="sng" algn="ctr">
+                      <a:noFill/>
+                    </a:lnT>
+                    <a:lnB w="0" cap="flat" cmpd="sng" algn="ctr">
+                      <a:noFill/>
+                    </a:lnB>
+                    <a:solidFill>
+                      <a:schemeClr val="bg2"/>
+                    </a:solidFill>
+                  </a:tcPr>
+                </a:tc>
+              </a:tr>
+              <a:tr h="310896">
+                <a:tc>
+                  <a:txBody>
+                    <a:bodyPr/>
+                    <a:lstStyle/>
+                    <a:p>
+                      <a:pPr algn="l" indent="0" marL="0">
+                        <a:buNone/>
+                      </a:pPr>
+                      <a:r>
+                        <a:rPr lang="en-US" sz="1400" dirty="0">
+                          <a:solidFill>
+                            <a:schemeClr val="tx1"/>
+                          </a:solidFill>
+                        </a:rPr>
+                        <a:t>de2_115_top</a:t>
+                      </a:r>
+                      <a:endParaRPr lang="en-US" sz="1400" dirty="0"/>
+                    </a:p>
+                  </a:txBody>
+                  <a:tcPr marL="91440" marR="91440" marT="45720" marB="45720" anchor="ctr">
+                    <a:lnL w="0" cap="flat" cmpd="sng" algn="ctr">
+                      <a:noFill/>
+                    </a:lnL>
+                    <a:lnR w="0" cap="flat" cmpd="sng" algn="ctr">
+                      <a:noFill/>
+                    </a:lnR>
+                    <a:lnT w="0" cap="flat" cmpd="sng" algn="ctr">
+                      <a:noFill/>
+                    </a:lnT>
+                    <a:lnB w="0" cap="flat" cmpd="sng" algn="ctr">
+                      <a:noFill/>
+                    </a:lnB>
+                    <a:solidFill>
+                      <a:schemeClr val="bg1"/>
+                    </a:solidFill>
+                  </a:tcPr>
+                </a:tc>
+                <a:tc>
+                  <a:txBody>
+                    <a:bodyPr/>
+                    <a:lstStyle/>
+                    <a:p>
+                      <a:pPr algn="l" indent="0" marL="0">
+                        <a:buNone/>
+                      </a:pPr>
+                      <a:r>
+                        <a:rPr lang="en-US" sz="1400" dirty="0">
+                          <a:solidFill>
+                            <a:schemeClr val="tx1"/>
+                          </a:solidFill>
+                        </a:rPr>
+                        <a:t>Board wrapper: keys, LEDs, UART</a:t>
+                      </a:r>
+                      <a:endParaRPr lang="en-US" sz="1400" dirty="0"/>
+                    </a:p>
+                  </a:txBody>
+                  <a:tcPr marL="91440" marR="91440" marT="45720" marB="45720" anchor="ctr">
+                    <a:lnL w="0" cap="flat" cmpd="sng" algn="ctr">
+                      <a:noFill/>
+                    </a:lnL>
+                    <a:lnR w="0" cap="flat" cmpd="sng" algn="ctr">
+                      <a:noFill/>
+                    </a:lnR>
+                    <a:lnT w="0" cap="flat" cmpd="sng" algn="ctr">
+                      <a:noFill/>
+                    </a:lnT>
+                    <a:lnB w="0" cap="flat" cmpd="sng" algn="ctr">
+                      <a:noFill/>
+                    </a:lnB>
+                    <a:solidFill>
                       <a:schemeClr val="bg1"/>
                     </a:solidFill>
                   </a:tcPr>
@@ -15351,7 +15577,7 @@
                             <a:schemeClr val="tx1"/>
                           </a:solidFill>
                         </a:rPr>
-                        <a:t>44</a:t>
+                        <a:t>18</a:t>
                       </a:r>
                       <a:endParaRPr lang="en-US" sz="1400" dirty="0"/>
                     </a:p>

</xml_diff>

<commit_message>
Add four-person review script; align AI timing figures in deck
Co-Authored-By: Claude Sonnet 5.5 <noreply@anthropic.com>
Claude-Session: https://claude.ai/code/session_01QAYZ6QSpvYPFSn8hrbYx5j
</commit_message>
<xml_diff>
--- a/docs/tactile_reflex_system.pptx
+++ b/docs/tactile_reflex_system.pptx
@@ -10582,7 +10582,7 @@
                   <a:schemeClr val="accent1"/>
                 </a:solidFill>
               </a:rPr>
-              <a:t>6.6 us</a:t>
+              <a:t>11 us</a:t>
             </a:r>
             <a:endParaRPr lang="en-US" sz="3200" dirty="0"/>
           </a:p>
@@ -10618,7 +10618,7 @@
                   <a:schemeClr val="tx1"/>
                 </a:solidFill>
               </a:rPr>
-              <a:t>median T_ML per decision (p99 22.9 us), measured on the development host</a:t>
+              <a:t>median T_ML per decision (p99 45 us; 6.6 to 11 us across runs), development host</a:t>
             </a:r>
             <a:endParaRPr lang="en-US" sz="1400" dirty="0"/>
           </a:p>
@@ -13188,7 +13188,7 @@
                   <a:schemeClr val="tx1"/>
                 </a:solidFill>
               </a:rPr>
-              <a:t>6.6 us</a:t>
+              <a:t>11 us</a:t>
             </a:r>
             <a:endParaRPr lang="en-US" sz="2800" dirty="0"/>
           </a:p>
@@ -16775,7 +16775,7 @@
                   <a:schemeClr val="tx1"/>
                 </a:solidFill>
               </a:rPr>
-              <a:t>Class 0 to 3 in about 7 us</a:t>
+              <a:t>Class 0 to 3 in about 10 us</a:t>
             </a:r>
             <a:endParaRPr lang="en-US" sz="1200" dirty="0"/>
           </a:p>

</xml_diff>